<commit_message>
chore: drop Cloudflare R2 references (R2 was never used)
Storage is Supabase Storage; R2 was never wired into the code (no R2_* usage,
no AWS SDK). Remove R2 from the infra deck + regenerate it, update the spec HTML
to Supabase Storage, and mark ADR-003 as superseded. (Remove the unused empty
R2_* vars from .env.local locally / don't carry them to the new environments.)

Co-Authored-By: Claude Opus 4.8 (1M context) <noreply@anthropic.com>
</commit_message>
<xml_diff>
--- a/presentations/Volunteer-Hub-Infrastructure.pptx
+++ b/presentations/Volunteer-Hub-Infrastructure.pptx
@@ -16837,8 +16837,8 @@
         </p:nvSpPr>
         <p:spPr>
           <a:xfrm>
-            <a:off x="7772400" y="3977639"/>
-            <a:ext cx="1188720" cy="777240"/>
+            <a:off x="8595360" y="3977639"/>
+            <a:ext cx="1417320" cy="777240"/>
           </a:xfrm>
           <a:prstGeom prst="roundRect">
             <a:avLst/>
@@ -16883,8 +16883,8 @@
         </p:nvSpPr>
         <p:spPr>
           <a:xfrm>
-            <a:off x="7845552" y="3977639"/>
-            <a:ext cx="1042416" cy="777240"/>
+            <a:off x="8668512" y="3977639"/>
+            <a:ext cx="1271016" cy="777240"/>
           </a:xfrm>
           <a:prstGeom prst="rect">
             <a:avLst/>
@@ -16944,8 +16944,8 @@
         </p:nvSpPr>
         <p:spPr>
           <a:xfrm>
-            <a:off x="9098280" y="3977639"/>
-            <a:ext cx="1234440" cy="777240"/>
+            <a:off x="10195560" y="3977639"/>
+            <a:ext cx="1417320" cy="777240"/>
           </a:xfrm>
           <a:prstGeom prst="roundRect">
             <a:avLst/>
@@ -16990,8 +16990,8 @@
         </p:nvSpPr>
         <p:spPr>
           <a:xfrm>
-            <a:off x="9171432" y="3977639"/>
-            <a:ext cx="1088136" cy="777240"/>
+            <a:off x="10268712" y="3977639"/>
+            <a:ext cx="1271016" cy="777240"/>
           </a:xfrm>
           <a:prstGeom prst="rect">
             <a:avLst/>
@@ -17043,113 +17043,78 @@
           </a:p>
         </p:txBody>
       </p:sp>
-      <p:sp>
-        <p:nvSpPr>
-          <p:cNvPr id="21" name="Rounded Rectangle 20"/>
-          <p:cNvSpPr/>
-          <p:nvPr/>
-        </p:nvSpPr>
-        <p:spPr>
-          <a:xfrm>
-            <a:off x="10469880" y="3977639"/>
-            <a:ext cx="1143000" cy="777240"/>
-          </a:xfrm>
-          <a:prstGeom prst="roundRect">
-            <a:avLst/>
-          </a:prstGeom>
-          <a:solidFill>
-            <a:srgbClr val="F3EFE6"/>
-          </a:solidFill>
-          <a:ln w="15875">
+      <p:cxnSp>
+        <p:nvCxnSpPr>
+          <p:cNvPr id="21" name="Connector 20"/>
+          <p:cNvCxnSpPr/>
+          <p:nvPr/>
+        </p:nvCxnSpPr>
+        <p:spPr>
+          <a:xfrm>
+            <a:off x="2834640" y="2258568"/>
+            <a:ext cx="1005840" cy="210312"/>
+          </a:xfrm>
+          <a:prstGeom prst="line">
+            <a:avLst/>
+          </a:prstGeom>
+          <a:ln w="22225">
             <a:solidFill>
-              <a:srgbClr val="E4DDD0"/>
+              <a:srgbClr val="A8854A"/>
             </a:solidFill>
+            <a:tailEnd type="triangle" w="med" len="med"/>
           </a:ln>
-          <a:effectLst/>
         </p:spPr>
         <p:style>
-          <a:lnRef idx="1">
+          <a:lnRef idx="2">
             <a:schemeClr val="accent1"/>
           </a:lnRef>
-          <a:fillRef idx="3">
+          <a:fillRef idx="0">
             <a:schemeClr val="accent1"/>
           </a:fillRef>
-          <a:effectRef idx="2">
+          <a:effectRef idx="1">
             <a:schemeClr val="accent1"/>
           </a:effectRef>
           <a:fontRef idx="minor">
-            <a:schemeClr val="lt1"/>
+            <a:schemeClr val="tx1"/>
           </a:fontRef>
         </p:style>
-        <p:txBody>
-          <a:bodyPr rtlCol="0" anchor="ctr"/>
-          <a:lstStyle/>
-          <a:p>
-            <a:pPr algn="ctr"/>
-          </a:p>
-        </p:txBody>
-      </p:sp>
-      <p:sp>
-        <p:nvSpPr>
-          <p:cNvPr id="22" name="TextBox 21"/>
-          <p:cNvSpPr txBox="1"/>
-          <p:nvPr/>
-        </p:nvSpPr>
-        <p:spPr>
-          <a:xfrm>
-            <a:off x="10543032" y="3977639"/>
-            <a:ext cx="996696" cy="777240"/>
-          </a:xfrm>
-          <a:prstGeom prst="rect">
-            <a:avLst/>
-          </a:prstGeom>
-          <a:noFill/>
-        </p:spPr>
-        <p:txBody>
-          <a:bodyPr wrap="square" anchor="ctr" lIns="25400" rIns="25400" tIns="12700" bIns="12700">
-            <a:spAutoFit/>
-          </a:bodyPr>
-          <a:lstStyle/>
-          <a:p>
-            <a:pPr algn="ctr">
-              <a:spcBef>
-                <a:spcPts val="0"/>
-              </a:spcBef>
-              <a:spcAft>
-                <a:spcPts val="200"/>
-              </a:spcAft>
-            </a:pPr>
-            <a:r>
-              <a:rPr sz="1000" b="1">
-                <a:solidFill>
-                  <a:srgbClr val="1A1714"/>
-                </a:solidFill>
-                <a:latin typeface="Calibri"/>
-              </a:rPr>
-              <a:t>R2</a:t>
-            </a:r>
-          </a:p>
-          <a:p>
-            <a:pPr algn="ctr">
-              <a:spcBef>
-                <a:spcPts val="0"/>
-              </a:spcBef>
-              <a:spcAft>
-                <a:spcPts val="0"/>
-              </a:spcAft>
-            </a:pPr>
-            <a:r>
-              <a:rPr sz="800" b="0">
-                <a:solidFill>
-                  <a:srgbClr val="78716C"/>
-                </a:solidFill>
-                <a:latin typeface="Calibri"/>
-              </a:rPr>
-              <a:t>Object store</a:t>
-            </a:r>
-          </a:p>
-        </p:txBody>
-      </p:sp>
+      </p:cxnSp>
+      <p:cxnSp>
+        <p:nvCxnSpPr>
+          <p:cNvPr id="22" name="Connector 21"/>
+          <p:cNvCxnSpPr/>
+          <p:nvPr/>
+        </p:nvCxnSpPr>
+        <p:spPr>
+          <a:xfrm flipV="1">
+            <a:off x="2834640" y="3200400"/>
+            <a:ext cx="1005840" cy="201168"/>
+          </a:xfrm>
+          <a:prstGeom prst="line">
+            <a:avLst/>
+          </a:prstGeom>
+          <a:ln w="22225">
+            <a:solidFill>
+              <a:srgbClr val="A8854A"/>
+            </a:solidFill>
+            <a:tailEnd type="triangle" w="med" len="med"/>
+          </a:ln>
+        </p:spPr>
+        <p:style>
+          <a:lnRef idx="2">
+            <a:schemeClr val="accent1"/>
+          </a:lnRef>
+          <a:fillRef idx="0">
+            <a:schemeClr val="accent1"/>
+          </a:fillRef>
+          <a:effectRef idx="1">
+            <a:schemeClr val="accent1"/>
+          </a:effectRef>
+          <a:fontRef idx="minor">
+            <a:schemeClr val="tx1"/>
+          </a:fontRef>
+        </p:style>
+      </p:cxnSp>
       <p:cxnSp>
         <p:nvCxnSpPr>
           <p:cNvPr id="23" name="Connector 22"/>
@@ -17157,9 +17122,9 @@
           <p:nvPr/>
         </p:nvCxnSpPr>
         <p:spPr>
-          <a:xfrm>
-            <a:off x="2834640" y="2258568"/>
-            <a:ext cx="1005840" cy="210312"/>
+          <a:xfrm flipV="1">
+            <a:off x="6766560" y="2194560"/>
+            <a:ext cx="1005840" cy="457200"/>
           </a:xfrm>
           <a:prstGeom prst="line">
             <a:avLst/>
@@ -17193,9 +17158,9 @@
           <p:nvPr/>
         </p:nvCxnSpPr>
         <p:spPr>
-          <a:xfrm flipV="1">
-            <a:off x="2834640" y="3200400"/>
-            <a:ext cx="1005840" cy="201168"/>
+          <a:xfrm>
+            <a:off x="6766560" y="3017520"/>
+            <a:ext cx="1005840" cy="182880"/>
           </a:xfrm>
           <a:prstGeom prst="line">
             <a:avLst/>
@@ -17230,8 +17195,8 @@
         </p:nvCxnSpPr>
         <p:spPr>
           <a:xfrm flipV="1">
-            <a:off x="6766560" y="2194560"/>
-            <a:ext cx="1005840" cy="457200"/>
+            <a:off x="6766560" y="3200400"/>
+            <a:ext cx="3017520" cy="182880"/>
           </a:xfrm>
           <a:prstGeom prst="line">
             <a:avLst/>
@@ -17266,15 +17231,15 @@
         </p:nvCxnSpPr>
         <p:spPr>
           <a:xfrm>
-            <a:off x="6766560" y="3017520"/>
-            <a:ext cx="1005840" cy="182880"/>
+            <a:off x="6766560" y="3657600"/>
+            <a:ext cx="1005840" cy="548640"/>
           </a:xfrm>
           <a:prstGeom prst="line">
             <a:avLst/>
           </a:prstGeom>
           <a:ln w="22225">
             <a:solidFill>
-              <a:srgbClr val="A8854A"/>
+              <a:srgbClr val="78716C"/>
             </a:solidFill>
             <a:tailEnd type="triangle" w="med" len="med"/>
           </a:ln>
@@ -17294,123 +17259,51 @@
           </a:fontRef>
         </p:style>
       </p:cxnSp>
-      <p:cxnSp>
-        <p:nvCxnSpPr>
-          <p:cNvPr id="27" name="Connector 26"/>
-          <p:cNvCxnSpPr/>
-          <p:nvPr/>
-        </p:nvCxnSpPr>
-        <p:spPr>
-          <a:xfrm flipV="1">
-            <a:off x="6766560" y="3200400"/>
-            <a:ext cx="3017520" cy="182880"/>
-          </a:xfrm>
-          <a:prstGeom prst="line">
-            <a:avLst/>
-          </a:prstGeom>
-          <a:ln w="22225">
-            <a:solidFill>
-              <a:srgbClr val="A8854A"/>
-            </a:solidFill>
-            <a:tailEnd type="triangle" w="med" len="med"/>
-          </a:ln>
-        </p:spPr>
-        <p:style>
-          <a:lnRef idx="2">
-            <a:schemeClr val="accent1"/>
-          </a:lnRef>
-          <a:fillRef idx="0">
-            <a:schemeClr val="accent1"/>
-          </a:fillRef>
-          <a:effectRef idx="1">
-            <a:schemeClr val="accent1"/>
-          </a:effectRef>
-          <a:fontRef idx="minor">
-            <a:schemeClr val="tx1"/>
-          </a:fontRef>
-        </p:style>
-      </p:cxnSp>
+      <p:sp>
+        <p:nvSpPr>
+          <p:cNvPr id="27" name="TextBox 26"/>
+          <p:cNvSpPr txBox="1"/>
+          <p:nvPr/>
+        </p:nvSpPr>
+        <p:spPr>
+          <a:xfrm>
+            <a:off x="3840480" y="4297680"/>
+            <a:ext cx="2926080" cy="457200"/>
+          </a:xfrm>
+          <a:prstGeom prst="rect">
+            <a:avLst/>
+          </a:prstGeom>
+          <a:noFill/>
+        </p:spPr>
+        <p:txBody>
+          <a:bodyPr wrap="square" anchor="t" lIns="25400" rIns="25400" tIns="12700" bIns="12700">
+            <a:spAutoFit/>
+          </a:bodyPr>
+          <a:lstStyle/>
+          <a:p>
+            <a:pPr algn="l">
+              <a:spcBef>
+                <a:spcPts val="0"/>
+              </a:spcBef>
+              <a:spcAft>
+                <a:spcPts val="0"/>
+              </a:spcAft>
+            </a:pPr>
+            <a:r>
+              <a:rPr sz="950" b="0">
+                <a:solidFill>
+                  <a:srgbClr val="78716C"/>
+                </a:solidFill>
+                <a:latin typeface="Calibri"/>
+              </a:rPr>
+              <a:t>Webhooks (delivery receipts) ← Resend / Voodoo</a:t>
+            </a:r>
+          </a:p>
+        </p:txBody>
+      </p:sp>
       <p:cxnSp>
         <p:nvCxnSpPr>
           <p:cNvPr id="28" name="Connector 27"/>
-          <p:cNvCxnSpPr/>
-          <p:nvPr/>
-        </p:nvCxnSpPr>
-        <p:spPr>
-          <a:xfrm>
-            <a:off x="6766560" y="3657600"/>
-            <a:ext cx="1005840" cy="548640"/>
-          </a:xfrm>
-          <a:prstGeom prst="line">
-            <a:avLst/>
-          </a:prstGeom>
-          <a:ln w="22225">
-            <a:solidFill>
-              <a:srgbClr val="78716C"/>
-            </a:solidFill>
-            <a:tailEnd type="triangle" w="med" len="med"/>
-          </a:ln>
-        </p:spPr>
-        <p:style>
-          <a:lnRef idx="2">
-            <a:schemeClr val="accent1"/>
-          </a:lnRef>
-          <a:fillRef idx="0">
-            <a:schemeClr val="accent1"/>
-          </a:fillRef>
-          <a:effectRef idx="1">
-            <a:schemeClr val="accent1"/>
-          </a:effectRef>
-          <a:fontRef idx="minor">
-            <a:schemeClr val="tx1"/>
-          </a:fontRef>
-        </p:style>
-      </p:cxnSp>
-      <p:sp>
-        <p:nvSpPr>
-          <p:cNvPr id="29" name="TextBox 28"/>
-          <p:cNvSpPr txBox="1"/>
-          <p:nvPr/>
-        </p:nvSpPr>
-        <p:spPr>
-          <a:xfrm>
-            <a:off x="3840480" y="4297680"/>
-            <a:ext cx="2926080" cy="457200"/>
-          </a:xfrm>
-          <a:prstGeom prst="rect">
-            <a:avLst/>
-          </a:prstGeom>
-          <a:noFill/>
-        </p:spPr>
-        <p:txBody>
-          <a:bodyPr wrap="square" anchor="t" lIns="25400" rIns="25400" tIns="12700" bIns="12700">
-            <a:spAutoFit/>
-          </a:bodyPr>
-          <a:lstStyle/>
-          <a:p>
-            <a:pPr algn="l">
-              <a:spcBef>
-                <a:spcPts val="0"/>
-              </a:spcBef>
-              <a:spcAft>
-                <a:spcPts val="0"/>
-              </a:spcAft>
-            </a:pPr>
-            <a:r>
-              <a:rPr sz="950" b="0">
-                <a:solidFill>
-                  <a:srgbClr val="78716C"/>
-                </a:solidFill>
-                <a:latin typeface="Calibri"/>
-              </a:rPr>
-              <a:t>Webhooks (delivery receipts) ← Resend / Voodoo</a:t>
-            </a:r>
-          </a:p>
-        </p:txBody>
-      </p:sp>
-      <p:cxnSp>
-        <p:nvCxnSpPr>
-          <p:cNvPr id="30" name="Connector 29"/>
           <p:cNvCxnSpPr/>
           <p:nvPr/>
         </p:nvCxnSpPr>
@@ -17447,7 +17340,7 @@
       </p:cxnSp>
       <p:sp>
         <p:nvSpPr>
-          <p:cNvPr id="31" name="Rounded Rectangle 30"/>
+          <p:cNvPr id="29" name="Rounded Rectangle 28"/>
           <p:cNvSpPr/>
           <p:nvPr/>
         </p:nvSpPr>
@@ -17491,7 +17384,7 @@
       </p:sp>
       <p:sp>
         <p:nvSpPr>
-          <p:cNvPr id="32" name="TextBox 31"/>
+          <p:cNvPr id="30" name="TextBox 29"/>
           <p:cNvSpPr txBox="1"/>
           <p:nvPr/>
         </p:nvSpPr>
@@ -17552,7 +17445,7 @@
       </p:sp>
       <p:sp>
         <p:nvSpPr>
-          <p:cNvPr id="33" name="TextBox 32"/>
+          <p:cNvPr id="31" name="TextBox 30"/>
           <p:cNvSpPr txBox="1"/>
           <p:nvPr/>
         </p:nvSpPr>
@@ -17594,7 +17487,7 @@
       </p:sp>
       <p:sp>
         <p:nvSpPr>
-          <p:cNvPr id="34" name="TextBox 33"/>
+          <p:cNvPr id="32" name="TextBox 31"/>
           <p:cNvSpPr txBox="1"/>
           <p:nvPr/>
         </p:nvSpPr>
@@ -20459,7 +20352,7 @@
         </p:nvGraphicFramePr>
         <p:xfrm>
           <a:off x="640080" y="2093976"/>
-          <a:ext cx="5577839" cy="1554480"/>
+          <a:ext cx="5577839" cy="1243584"/>
         </p:xfrm>
         <a:graphic>
           <a:graphicData uri="http://schemas.openxmlformats.org/drawingml/2006/table">
@@ -20651,52 +20544,6 @@
                   <a:tcPr marL="76200" marT="12700" marB="12700" anchor="ctr">
                     <a:solidFill>
                       <a:srgbClr val="FFFFFF"/>
-                    </a:solidFill>
-                  </a:tcPr>
-                </a:tc>
-              </a:tr>
-              <a:tr h="310896">
-                <a:tc>
-                  <a:txBody>
-                    <a:bodyPr/>
-                    <a:lstStyle/>
-                    <a:p>
-                      <a:r>
-                        <a:rPr sz="969" b="1">
-                          <a:solidFill>
-                            <a:srgbClr val="1A1714"/>
-                          </a:solidFill>
-                          <a:latin typeface="Calibri"/>
-                        </a:rPr>
-                        <a:t>Cloudflare R2</a:t>
-                      </a:r>
-                    </a:p>
-                  </a:txBody>
-                  <a:tcPr marL="76200" marT="12700" marB="12700" anchor="ctr">
-                    <a:solidFill>
-                      <a:srgbClr val="F3EFE6"/>
-                    </a:solidFill>
-                  </a:tcPr>
-                </a:tc>
-                <a:tc>
-                  <a:txBody>
-                    <a:bodyPr/>
-                    <a:lstStyle/>
-                    <a:p>
-                      <a:r>
-                        <a:rPr sz="919" b="0">
-                          <a:solidFill>
-                            <a:srgbClr val="78716C"/>
-                          </a:solidFill>
-                          <a:latin typeface="Calibri"/>
-                        </a:rPr>
-                        <a:t>Object storage (assets)</a:t>
-                      </a:r>
-                    </a:p>
-                  </a:txBody>
-                  <a:tcPr marL="76200" marT="12700" marB="12700" anchor="ctr">
-                    <a:solidFill>
-                      <a:srgbClr val="F3EFE6"/>
                     </a:solidFill>
                   </a:tcPr>
                 </a:tc>
@@ -24071,4 +23918,225 @@
   </a:objectDefaults>
   <a:extraClrSchemeLst/>
 </a:theme>
+</file>
+
+<file path=customXml/item1.xml><?xml version="1.0" encoding="utf-8"?>
+<ct:contentTypeSchema xmlns:ct="http://schemas.microsoft.com/office/2006/metadata/contentType" xmlns:ma="http://schemas.microsoft.com/office/2006/metadata/properties/metaAttributes" ct:_="" ma:_="" ma:contentTypeName="Document" ma:contentTypeID="0x01010057E2541DCC01DB46990F58586613796A" ma:contentTypeVersion="10" ma:contentTypeDescription="Create a new document." ma:contentTypeScope="" ma:versionID="a90d7132ac4f3931d68ad6411d8f31b0">
+  <xsd:schema xmlns:xsd="http://www.w3.org/2001/XMLSchema" xmlns:xs="http://www.w3.org/2001/XMLSchema" xmlns:p="http://schemas.microsoft.com/office/2006/metadata/properties" xmlns:ns2="f7c7c626-9fa3-4c23-8f64-81f8f5315147" xmlns:ns3="719c117a-d53d-4b0b-9099-ce4de524880a" targetNamespace="http://schemas.microsoft.com/office/2006/metadata/properties" ma:root="true" ma:fieldsID="2b6d06f4e11a4dc4b68177adcad54638" ns2:_="" ns3:_="">
+    <xsd:import namespace="f7c7c626-9fa3-4c23-8f64-81f8f5315147"/>
+    <xsd:import namespace="719c117a-d53d-4b0b-9099-ce4de524880a"/>
+    <xsd:element name="properties">
+      <xsd:complexType>
+        <xsd:sequence>
+          <xsd:element name="documentManagement">
+            <xsd:complexType>
+              <xsd:all>
+                <xsd:element ref="ns2:MediaServiceMetadata" minOccurs="0"/>
+                <xsd:element ref="ns2:MediaServiceFastMetadata" minOccurs="0"/>
+                <xsd:element ref="ns2:MediaServiceSearchProperties" minOccurs="0"/>
+                <xsd:element ref="ns2:MediaServiceDateTaken" minOccurs="0"/>
+                <xsd:element ref="ns2:lcf76f155ced4ddcb4097134ff3c332f" minOccurs="0"/>
+                <xsd:element ref="ns3:TaxCatchAll" minOccurs="0"/>
+                <xsd:element ref="ns2:MediaServiceOCR" minOccurs="0"/>
+                <xsd:element ref="ns2:MediaServiceGenerationTime" minOccurs="0"/>
+                <xsd:element ref="ns2:MediaServiceEventHashCode" minOccurs="0"/>
+              </xsd:all>
+            </xsd:complexType>
+          </xsd:element>
+        </xsd:sequence>
+      </xsd:complexType>
+    </xsd:element>
+  </xsd:schema>
+  <xsd:schema xmlns:xsd="http://www.w3.org/2001/XMLSchema" xmlns:xs="http://www.w3.org/2001/XMLSchema" xmlns:dms="http://schemas.microsoft.com/office/2006/documentManagement/types" xmlns:pc="http://schemas.microsoft.com/office/infopath/2007/PartnerControls" targetNamespace="f7c7c626-9fa3-4c23-8f64-81f8f5315147" elementFormDefault="qualified">
+    <xsd:import namespace="http://schemas.microsoft.com/office/2006/documentManagement/types"/>
+    <xsd:import namespace="http://schemas.microsoft.com/office/infopath/2007/PartnerControls"/>
+    <xsd:element name="MediaServiceMetadata" ma:index="8" nillable="true" ma:displayName="MediaServiceMetadata" ma:hidden="true" ma:internalName="MediaServiceMetadata" ma:readOnly="true">
+      <xsd:simpleType>
+        <xsd:restriction base="dms:Note"/>
+      </xsd:simpleType>
+    </xsd:element>
+    <xsd:element name="MediaServiceFastMetadata" ma:index="9" nillable="true" ma:displayName="MediaServiceFastMetadata" ma:hidden="true" ma:internalName="MediaServiceFastMetadata" ma:readOnly="true">
+      <xsd:simpleType>
+        <xsd:restriction base="dms:Note"/>
+      </xsd:simpleType>
+    </xsd:element>
+    <xsd:element name="MediaServiceSearchProperties" ma:index="10" nillable="true" ma:displayName="MediaServiceSearchProperties" ma:hidden="true" ma:internalName="MediaServiceSearchProperties" ma:readOnly="true">
+      <xsd:simpleType>
+        <xsd:restriction base="dms:Note"/>
+      </xsd:simpleType>
+    </xsd:element>
+    <xsd:element name="MediaServiceDateTaken" ma:index="11" nillable="true" ma:displayName="MediaServiceDateTaken" ma:hidden="true" ma:indexed="true" ma:internalName="MediaServiceDateTaken" ma:readOnly="true">
+      <xsd:simpleType>
+        <xsd:restriction base="dms:Text"/>
+      </xsd:simpleType>
+    </xsd:element>
+    <xsd:element name="lcf76f155ced4ddcb4097134ff3c332f" ma:index="13" nillable="true" ma:taxonomy="true" ma:internalName="lcf76f155ced4ddcb4097134ff3c332f" ma:taxonomyFieldName="MediaServiceImageTags" ma:displayName="Image Tags" ma:readOnly="false" ma:fieldId="{5cf76f15-5ced-4ddc-b409-7134ff3c332f}" ma:taxonomyMulti="true" ma:sspId="3f8da4b4-a0a8-4b8f-8b2d-31d8271955b8" ma:termSetId="09814cd3-568e-fe90-9814-8d621ff8fb84" ma:anchorId="fba54fb3-c3e1-fe81-a776-ca4b69148c4d" ma:open="true" ma:isKeyword="false">
+      <xsd:complexType>
+        <xsd:sequence>
+          <xsd:element ref="pc:Terms" minOccurs="0" maxOccurs="1"/>
+        </xsd:sequence>
+      </xsd:complexType>
+    </xsd:element>
+    <xsd:element name="MediaServiceOCR" ma:index="15" nillable="true" ma:displayName="Extracted Text" ma:internalName="MediaServiceOCR" ma:readOnly="true">
+      <xsd:simpleType>
+        <xsd:restriction base="dms:Note">
+          <xsd:maxLength value="255"/>
+        </xsd:restriction>
+      </xsd:simpleType>
+    </xsd:element>
+    <xsd:element name="MediaServiceGenerationTime" ma:index="16" nillable="true" ma:displayName="MediaServiceGenerationTime" ma:hidden="true" ma:internalName="MediaServiceGenerationTime" ma:readOnly="true">
+      <xsd:simpleType>
+        <xsd:restriction base="dms:Text"/>
+      </xsd:simpleType>
+    </xsd:element>
+    <xsd:element name="MediaServiceEventHashCode" ma:index="17" nillable="true" ma:displayName="MediaServiceEventHashCode" ma:hidden="true" ma:internalName="MediaServiceEventHashCode" ma:readOnly="true">
+      <xsd:simpleType>
+        <xsd:restriction base="dms:Text"/>
+      </xsd:simpleType>
+    </xsd:element>
+  </xsd:schema>
+  <xsd:schema xmlns:xsd="http://www.w3.org/2001/XMLSchema" xmlns:xs="http://www.w3.org/2001/XMLSchema" xmlns:dms="http://schemas.microsoft.com/office/2006/documentManagement/types" xmlns:pc="http://schemas.microsoft.com/office/infopath/2007/PartnerControls" targetNamespace="719c117a-d53d-4b0b-9099-ce4de524880a" elementFormDefault="qualified">
+    <xsd:import namespace="http://schemas.microsoft.com/office/2006/documentManagement/types"/>
+    <xsd:import namespace="http://schemas.microsoft.com/office/infopath/2007/PartnerControls"/>
+    <xsd:element name="TaxCatchAll" ma:index="14" nillable="true" ma:displayName="Taxonomy Catch All Column" ma:hidden="true" ma:list="{cf3deb31-fc00-4363-9f23-adc42edff313}" ma:internalName="TaxCatchAll" ma:showField="CatchAllData" ma:web="719c117a-d53d-4b0b-9099-ce4de524880a">
+      <xsd:complexType>
+        <xsd:complexContent>
+          <xsd:extension base="dms:MultiChoiceLookup">
+            <xsd:sequence>
+              <xsd:element name="Value" type="dms:Lookup" maxOccurs="unbounded" minOccurs="0" nillable="true"/>
+            </xsd:sequence>
+          </xsd:extension>
+        </xsd:complexContent>
+      </xsd:complexType>
+    </xsd:element>
+  </xsd:schema>
+  <xsd:schema xmlns="http://schemas.openxmlformats.org/package/2006/metadata/core-properties" xmlns:xsd="http://www.w3.org/2001/XMLSchema" xmlns:xsi="http://www.w3.org/2001/XMLSchema-instance" xmlns:dc="http://purl.org/dc/elements/1.1/" xmlns:dcterms="http://purl.org/dc/terms/" xmlns:odoc="http://schemas.microsoft.com/internal/obd" targetNamespace="http://schemas.openxmlformats.org/package/2006/metadata/core-properties" elementFormDefault="qualified" attributeFormDefault="unqualified" blockDefault="#all">
+    <xsd:import namespace="http://purl.org/dc/elements/1.1/" schemaLocation="http://dublincore.org/schemas/xmls/qdc/2003/04/02/dc.xsd"/>
+    <xsd:import namespace="http://purl.org/dc/terms/" schemaLocation="http://dublincore.org/schemas/xmls/qdc/2003/04/02/dcterms.xsd"/>
+    <xsd:element name="coreProperties" type="CT_coreProperties"/>
+    <xsd:complexType name="CT_coreProperties">
+      <xsd:all>
+        <xsd:element ref="dc:creator" minOccurs="0" maxOccurs="1"/>
+        <xsd:element ref="dcterms:created" minOccurs="0" maxOccurs="1"/>
+        <xsd:element ref="dc:identifier" minOccurs="0" maxOccurs="1"/>
+        <xsd:element name="contentType" minOccurs="0" maxOccurs="1" type="xsd:string" ma:index="0" ma:displayName="Content Type"/>
+        <xsd:element ref="dc:title" minOccurs="0" maxOccurs="1" ma:index="4" ma:displayName="Title"/>
+        <xsd:element ref="dc:subject" minOccurs="0" maxOccurs="1"/>
+        <xsd:element ref="dc:description" minOccurs="0" maxOccurs="1"/>
+        <xsd:element name="keywords" minOccurs="0" maxOccurs="1" type="xsd:string"/>
+        <xsd:element ref="dc:language" minOccurs="0" maxOccurs="1"/>
+        <xsd:element name="category" minOccurs="0" maxOccurs="1" type="xsd:string"/>
+        <xsd:element name="version" minOccurs="0" maxOccurs="1" type="xsd:string"/>
+        <xsd:element name="revision" minOccurs="0" maxOccurs="1" type="xsd:string">
+          <xsd:annotation>
+            <xsd:documentation>
+                        This value indicates the number of saves or revisions. The application is responsible for updating this value after each revision.
+                    </xsd:documentation>
+          </xsd:annotation>
+        </xsd:element>
+        <xsd:element name="lastModifiedBy" minOccurs="0" maxOccurs="1" type="xsd:string"/>
+        <xsd:element ref="dcterms:modified" minOccurs="0" maxOccurs="1"/>
+        <xsd:element name="contentStatus" minOccurs="0" maxOccurs="1" type="xsd:string"/>
+      </xsd:all>
+    </xsd:complexType>
+  </xsd:schema>
+  <xs:schema xmlns:pc="http://schemas.microsoft.com/office/infopath/2007/PartnerControls" xmlns:xs="http://www.w3.org/2001/XMLSchema" targetNamespace="http://schemas.microsoft.com/office/infopath/2007/PartnerControls" elementFormDefault="qualified" attributeFormDefault="unqualified">
+    <xs:element name="Person">
+      <xs:complexType>
+        <xs:sequence>
+          <xs:element ref="pc:DisplayName" minOccurs="0"/>
+          <xs:element ref="pc:AccountId" minOccurs="0"/>
+          <xs:element ref="pc:AccountType" minOccurs="0"/>
+        </xs:sequence>
+      </xs:complexType>
+    </xs:element>
+    <xs:element name="DisplayName" type="xs:string"/>
+    <xs:element name="AccountId" type="xs:string"/>
+    <xs:element name="AccountType" type="xs:string"/>
+    <xs:element name="BDCAssociatedEntity">
+      <xs:complexType>
+        <xs:sequence>
+          <xs:element ref="pc:BDCEntity" minOccurs="0" maxOccurs="unbounded"/>
+        </xs:sequence>
+        <xs:attribute ref="pc:EntityNamespace"/>
+        <xs:attribute ref="pc:EntityName"/>
+        <xs:attribute ref="pc:SystemInstanceName"/>
+        <xs:attribute ref="pc:AssociationName"/>
+      </xs:complexType>
+    </xs:element>
+    <xs:attribute name="EntityNamespace" type="xs:string"/>
+    <xs:attribute name="EntityName" type="xs:string"/>
+    <xs:attribute name="SystemInstanceName" type="xs:string"/>
+    <xs:attribute name="AssociationName" type="xs:string"/>
+    <xs:element name="BDCEntity">
+      <xs:complexType>
+        <xs:sequence>
+          <xs:element ref="pc:EntityDisplayName" minOccurs="0"/>
+          <xs:element ref="pc:EntityInstanceReference" minOccurs="0"/>
+          <xs:element ref="pc:EntityId1" minOccurs="0"/>
+          <xs:element ref="pc:EntityId2" minOccurs="0"/>
+          <xs:element ref="pc:EntityId3" minOccurs="0"/>
+          <xs:element ref="pc:EntityId4" minOccurs="0"/>
+          <xs:element ref="pc:EntityId5" minOccurs="0"/>
+        </xs:sequence>
+      </xs:complexType>
+    </xs:element>
+    <xs:element name="EntityDisplayName" type="xs:string"/>
+    <xs:element name="EntityInstanceReference" type="xs:string"/>
+    <xs:element name="EntityId1" type="xs:string"/>
+    <xs:element name="EntityId2" type="xs:string"/>
+    <xs:element name="EntityId3" type="xs:string"/>
+    <xs:element name="EntityId4" type="xs:string"/>
+    <xs:element name="EntityId5" type="xs:string"/>
+    <xs:element name="Terms">
+      <xs:complexType>
+        <xs:sequence>
+          <xs:element ref="pc:TermInfo" minOccurs="0" maxOccurs="unbounded"/>
+        </xs:sequence>
+      </xs:complexType>
+    </xs:element>
+    <xs:element name="TermInfo">
+      <xs:complexType>
+        <xs:sequence>
+          <xs:element ref="pc:TermName" minOccurs="0"/>
+          <xs:element ref="pc:TermId" minOccurs="0"/>
+        </xs:sequence>
+      </xs:complexType>
+    </xs:element>
+    <xs:element name="TermName" type="xs:string"/>
+    <xs:element name="TermId" type="xs:string"/>
+  </xs:schema>
+</ct:contentTypeSchema>
+</file>
+
+<file path=customXml/item2.xml><?xml version="1.0" encoding="utf-8"?>
+<?mso-contentType ?>
+<FormTemplates xmlns="http://schemas.microsoft.com/sharepoint/v3/contenttype/forms">
+  <Display>DocumentLibraryForm</Display>
+  <Edit>DocumentLibraryForm</Edit>
+  <New>DocumentLibraryForm</New>
+</FormTemplates>
+</file>
+
+<file path=customXml/item3.xml><?xml version="1.0" encoding="utf-8"?>
+<p:properties xmlns:p="http://schemas.microsoft.com/office/2006/metadata/properties" xmlns:xsi="http://www.w3.org/2001/XMLSchema-instance" xmlns:pc="http://schemas.microsoft.com/office/infopath/2007/PartnerControls">
+  <documentManagement>
+    <TaxCatchAll xmlns="719c117a-d53d-4b0b-9099-ce4de524880a" xsi:nil="true"/>
+    <lcf76f155ced4ddcb4097134ff3c332f xmlns="f7c7c626-9fa3-4c23-8f64-81f8f5315147">
+      <Terms xmlns="http://schemas.microsoft.com/office/infopath/2007/PartnerControls"/>
+    </lcf76f155ced4ddcb4097134ff3c332f>
+  </documentManagement>
+</p:properties>
+</file>
+
+<file path=customXml/itemProps1.xml><?xml version="1.0" encoding="utf-8"?>
+<ds:datastoreItem xmlns:ds="http://schemas.openxmlformats.org/officeDocument/2006/customXml" ds:itemID="{1B501845-185D-4463-A321-FA8C08AD8342}"/>
+</file>
+
+<file path=customXml/itemProps2.xml><?xml version="1.0" encoding="utf-8"?>
+<ds:datastoreItem xmlns:ds="http://schemas.openxmlformats.org/officeDocument/2006/customXml" ds:itemID="{5B339F74-F55A-4475-B0B7-1A098177145A}"/>
+</file>
+
+<file path=customXml/itemProps3.xml><?xml version="1.0" encoding="utf-8"?>
+<ds:datastoreItem xmlns:ds="http://schemas.openxmlformats.org/officeDocument/2006/customXml" ds:itemID="{9DC8A0C9-7DB6-46A3-967D-14D61A48DD5D}"/>
 </file>
</xml_diff>